<commit_message>
feat: add polymathics strategies page
</commit_message>
<xml_diff>
--- a/Pitchbooks/Polymathics_Template.pptx
+++ b/Pitchbooks/Polymathics_Template.pptx
@@ -4,6 +4,9 @@
   <p:sldMasterIdLst>
     <p:sldMasterId id="2147483648" r:id="rId1"/>
   </p:sldMasterIdLst>
+  <p:notesMasterIdLst>
+    <p:notesMasterId r:id="rId9"/>
+  </p:notesMasterIdLst>
   <p:sldIdLst>
     <p:sldId id="256" r:id="rId2"/>
     <p:sldId id="257" r:id="rId3"/>
@@ -13,10 +16,7 @@
     <p:sldId id="261" r:id="rId7"/>
     <p:sldId id="262" r:id="rId8"/>
   </p:sldIdLst>
-  <p:notesMasterIdLst>
-    <p:notesMasterId r:id="rId9"/>
-  </p:notesMasterIdLst>
-  <p:sldSz cx="9144000" cy="5143500"/>
+  <p:sldSz cx="9144000" cy="5143500" type="screen16x9"/>
   <p:notesSz cx="5143500" cy="9144000"/>
   <p:defaultTextStyle>
     <a:lvl1pPr marL="0" algn="l" defTabSz="914400" rtl="0" eaLnBrk="1" latinLnBrk="0" hangingPunct="1">
@@ -110,6 +110,11 @@
       </a:defRPr>
     </a:lvl9pPr>
   </p:defaultTextStyle>
+  <p:extLst>
+    <p:ext uri="{EFAFB233-063F-42B5-8137-9DF3F51BA10A}">
+      <p15:sldGuideLst xmlns:p15="http://schemas.microsoft.com/office/powerpoint/2012/main"/>
+    </p:ext>
+  </p:extLst>
 </p:presentation>
 </file>
 
@@ -135,234 +140,10 @@
           <a:chExt cx="0" cy="0"/>
         </a:xfrm>
       </p:grpSpPr>
-      <p:sp>
-        <p:nvSpPr>
-          <p:cNvPr id="2" name="Header Placeholder 1"/>
-          <p:cNvSpPr>
-            <a:spLocks noGrp="1"/>
-          </p:cNvSpPr>
-          <p:nvPr>
-            <p:ph type="hdr" sz="quarter"/>
-          </p:nvPr>
-        </p:nvSpPr>
-        <p:spPr>
-          <a:xfrm>
-            <a:off x="0" y="0"/>
-            <a:ext cx="2971800" cy="458788"/>
-          </a:xfrm>
-          <a:prstGeom prst="rect">
-            <a:avLst/>
-          </a:prstGeom>
-        </p:spPr>
-        <p:txBody>
-          <a:bodyPr vert="horz" lIns="91440" tIns="45720" rIns="91440" bIns="45720" rtlCol="0"/>
-          <a:lstStyle>
-            <a:lvl1pPr algn="l">
-              <a:defRPr sz="1200"/>
-            </a:lvl1pPr>
-          </a:lstStyle>
-          <a:p>
-            <a:endParaRPr lang="en-US"/>
-          </a:p>
-        </p:txBody>
-      </p:sp>
-      <p:sp>
-        <p:nvSpPr>
-          <p:cNvPr id="3" name="Date Placeholder 2"/>
-          <p:cNvSpPr>
-            <a:spLocks noGrp="1"/>
-          </p:cNvSpPr>
-          <p:nvPr>
-            <p:ph type="dt" idx="1"/>
-          </p:nvPr>
-        </p:nvSpPr>
-        <p:spPr>
-          <a:xfrm>
-            <a:off x="3884613" y="0"/>
-            <a:ext cx="2971800" cy="458788"/>
-          </a:xfrm>
-          <a:prstGeom prst="rect">
-            <a:avLst/>
-          </a:prstGeom>
-        </p:spPr>
-        <p:txBody>
-          <a:bodyPr vert="horz" lIns="91440" tIns="45720" rIns="91440" bIns="45720" rtlCol="0"/>
-          <a:lstStyle>
-            <a:lvl1pPr algn="r">
-              <a:defRPr sz="1200"/>
-            </a:lvl1pPr>
-          </a:lstStyle>
-          <a:p>
-            <a:fld id="{5282F153-3F37-0F45-9E97-73ACFA13230C}" type="datetimeFigureOut">
-              <a:rPr lang="en-US"/>
-              <a:t>7/23/19</a:t>
-            </a:fld>
-            <a:endParaRPr lang="en-US"/>
-          </a:p>
-        </p:txBody>
-      </p:sp>
-      <p:sp>
-        <p:nvSpPr>
-          <p:cNvPr id="4" name="Slide Image Placeholder 3"/>
-          <p:cNvSpPr>
-            <a:spLocks noGrp="1" noRot="1" noChangeAspect="1"/>
-          </p:cNvSpPr>
-          <p:nvPr>
-            <p:ph type="sldImg" idx="2"/>
-          </p:nvPr>
-        </p:nvSpPr>
-        <p:spPr>
-          <a:xfrm>
-            <a:off x="685800" y="1143000"/>
-            <a:ext cx="5486400" cy="3086100"/>
-          </a:xfrm>
-          <a:prstGeom prst="rect">
-            <a:avLst/>
-          </a:prstGeom>
-          <a:noFill/>
-          <a:ln w="12700">
-            <a:solidFill>
-              <a:prstClr val="black"/>
-            </a:solidFill>
-          </a:ln>
-        </p:spPr>
-        <p:txBody>
-          <a:bodyPr vert="horz" lIns="91440" tIns="45720" rIns="91440" bIns="45720" rtlCol="0" anchor="ctr"/>
-          <a:lstStyle/>
-          <a:p>
-            <a:endParaRPr lang="en-US"/>
-          </a:p>
-        </p:txBody>
-      </p:sp>
-      <p:sp>
-        <p:nvSpPr>
-          <p:cNvPr id="5" name="Notes Placeholder 4"/>
-          <p:cNvSpPr>
-            <a:spLocks noGrp="1"/>
-          </p:cNvSpPr>
-          <p:nvPr>
-            <p:ph type="body" sz="quarter" idx="3"/>
-          </p:nvPr>
-        </p:nvSpPr>
-        <p:spPr>
-          <a:xfrm>
-            <a:off x="685800" y="4400550"/>
-            <a:ext cx="5486400" cy="3600450"/>
-          </a:xfrm>
-          <a:prstGeom prst="rect">
-            <a:avLst/>
-          </a:prstGeom>
-        </p:spPr>
-        <p:txBody>
-          <a:bodyPr vert="horz" lIns="91440" tIns="45720" rIns="91440" bIns="45720" rtlCol="0"/>
-          <a:lstStyle/>
-          <a:p>
-            <a:pPr lvl="0"/>
-            <a:r>
-              <a:rPr lang="en-US"/>
-              <a:t>Click to edit Master text styles</a:t>
-            </a:r>
-          </a:p>
-          <a:p>
-            <a:pPr lvl="1"/>
-            <a:r>
-              <a:rPr lang="en-US"/>
-              <a:t>Second level</a:t>
-            </a:r>
-          </a:p>
-          <a:p>
-            <a:pPr lvl="2"/>
-            <a:r>
-              <a:rPr lang="en-US"/>
-              <a:t>Third level</a:t>
-            </a:r>
-          </a:p>
-          <a:p>
-            <a:pPr lvl="3"/>
-            <a:r>
-              <a:rPr lang="en-US"/>
-              <a:t>Fourth level</a:t>
-            </a:r>
-          </a:p>
-          <a:p>
-            <a:pPr lvl="4"/>
-            <a:r>
-              <a:rPr lang="en-US"/>
-              <a:t>Fifth level</a:t>
-            </a:r>
-          </a:p>
-        </p:txBody>
-      </p:sp>
-      <p:sp>
-        <p:nvSpPr>
-          <p:cNvPr id="6" name="Footer Placeholder 5"/>
-          <p:cNvSpPr>
-            <a:spLocks noGrp="1"/>
-          </p:cNvSpPr>
-          <p:nvPr>
-            <p:ph type="ftr" sz="quarter" idx="4"/>
-          </p:nvPr>
-        </p:nvSpPr>
-        <p:spPr>
-          <a:xfrm>
-            <a:off x="0" y="8685213"/>
-            <a:ext cx="2971800" cy="458787"/>
-          </a:xfrm>
-          <a:prstGeom prst="rect">
-            <a:avLst/>
-          </a:prstGeom>
-        </p:spPr>
-        <p:txBody>
-          <a:bodyPr vert="horz" lIns="91440" tIns="45720" rIns="91440" bIns="45720" rtlCol="0" anchor="b"/>
-          <a:lstStyle>
-            <a:lvl1pPr algn="l">
-              <a:defRPr sz="1200"/>
-            </a:lvl1pPr>
-          </a:lstStyle>
-          <a:p>
-            <a:endParaRPr lang="en-US"/>
-          </a:p>
-        </p:txBody>
-      </p:sp>
-      <p:sp>
-        <p:nvSpPr>
-          <p:cNvPr id="7" name="Slide Number Placeholder 6"/>
-          <p:cNvSpPr>
-            <a:spLocks noGrp="1"/>
-          </p:cNvSpPr>
-          <p:nvPr>
-            <p:ph type="sldNum" sz="quarter" idx="5"/>
-          </p:nvPr>
-        </p:nvSpPr>
-        <p:spPr>
-          <a:xfrm>
-            <a:off x="3884613" y="8685213"/>
-            <a:ext cx="2971800" cy="458787"/>
-          </a:xfrm>
-          <a:prstGeom prst="rect">
-            <a:avLst/>
-          </a:prstGeom>
-        </p:spPr>
-        <p:txBody>
-          <a:bodyPr vert="horz" lIns="91440" tIns="45720" rIns="91440" bIns="45720" rtlCol="0" anchor="b"/>
-          <a:lstStyle>
-            <a:lvl1pPr algn="r">
-              <a:defRPr sz="1200"/>
-            </a:lvl1pPr>
-          </a:lstStyle>
-          <a:p>
-            <a:fld id="{CE5E9CC1-C706-0F49-92D6-E571CC5EEA8F}" type="slidenum">
-              <a:rPr lang="en-US"/>
-              <a:t>‹#›</a:t>
-            </a:fld>
-            <a:endParaRPr lang="en-US"/>
-          </a:p>
-        </p:txBody>
-      </p:sp>
     </p:spTree>
     <p:extLst>
       <p:ext uri="{BB962C8B-B14F-4D97-AF65-F5344CB8AC3E}">
-        <p14:creationId xmlns:p14="http://schemas.microsoft.com/office/powerpoint/2010/main" val="1024086991"/>
+        <p14:creationId xmlns:p14="http://schemas.microsoft.com/office/powerpoint/2010/main" val="3228084066"/>
       </p:ext>
     </p:extLst>
   </p:cSld>
@@ -506,10 +287,6 @@
           <a:bodyPr/>
           <a:lstStyle/>
           <a:p>
-            <a:r>
-              <a:rPr lang="en-US" dirty="0"/>
-              <a:t/>
-            </a:r>
             <a:endParaRPr lang="en-US" dirty="0"/>
           </a:p>
         </p:txBody>
@@ -594,10 +371,6 @@
           <a:bodyPr/>
           <a:lstStyle/>
           <a:p>
-            <a:r>
-              <a:rPr lang="en-US" dirty="0"/>
-              <a:t/>
-            </a:r>
             <a:endParaRPr lang="en-US" dirty="0"/>
           </a:p>
         </p:txBody>
@@ -682,10 +455,6 @@
           <a:bodyPr/>
           <a:lstStyle/>
           <a:p>
-            <a:r>
-              <a:rPr lang="en-US" dirty="0"/>
-              <a:t/>
-            </a:r>
             <a:endParaRPr lang="en-US" dirty="0"/>
           </a:p>
         </p:txBody>
@@ -770,10 +539,6 @@
           <a:bodyPr/>
           <a:lstStyle/>
           <a:p>
-            <a:r>
-              <a:rPr lang="en-US" dirty="0"/>
-              <a:t/>
-            </a:r>
             <a:endParaRPr lang="en-US" dirty="0"/>
           </a:p>
         </p:txBody>
@@ -858,10 +623,6 @@
           <a:bodyPr/>
           <a:lstStyle/>
           <a:p>
-            <a:r>
-              <a:rPr lang="en-US" dirty="0"/>
-              <a:t/>
-            </a:r>
             <a:endParaRPr lang="en-US" dirty="0"/>
           </a:p>
         </p:txBody>
@@ -946,10 +707,6 @@
           <a:bodyPr/>
           <a:lstStyle/>
           <a:p>
-            <a:r>
-              <a:rPr lang="en-US" dirty="0"/>
-              <a:t/>
-            </a:r>
             <a:endParaRPr lang="en-US" dirty="0"/>
           </a:p>
         </p:txBody>
@@ -1034,10 +791,6 @@
           <a:bodyPr/>
           <a:lstStyle/>
           <a:p>
-            <a:r>
-              <a:rPr lang="en-US" dirty="0"/>
-              <a:t/>
-            </a:r>
             <a:endParaRPr lang="en-US" dirty="0"/>
           </a:p>
         </p:txBody>
@@ -1111,6 +864,11 @@
 <file path=ppt/slideMasters/slideMaster1.xml><?xml version="1.0" encoding="utf-8"?>
 <p:sldMaster xmlns:a="http://schemas.openxmlformats.org/drawingml/2006/main" xmlns:r="http://schemas.openxmlformats.org/officeDocument/2006/relationships" xmlns:p="http://schemas.openxmlformats.org/presentationml/2006/main">
   <p:cSld>
+    <p:bg>
+      <p:bgRef idx="1001">
+        <a:schemeClr val="bg1"/>
+      </p:bgRef>
+    </p:bg>
     <p:spTree>
       <p:nvGrpSpPr>
         <p:cNvPr id="1" name=""/>
@@ -1393,6 +1151,7 @@
         <a:solidFill>
           <a:srgbClr val="0D0D78"/>
         </a:solidFill>
+        <a:effectLst/>
       </p:bgPr>
     </p:bg>
     <p:spTree>
@@ -1433,6 +1192,13 @@
             <a:prstDash val="solid"/>
           </a:ln>
         </p:spPr>
+        <p:txBody>
+          <a:bodyPr/>
+          <a:lstStyle/>
+          <a:p>
+            <a:endParaRPr lang="en-US"/>
+          </a:p>
+        </p:txBody>
       </p:sp>
       <p:sp>
         <p:nvSpPr>
@@ -1458,6 +1224,13 @@
             <a:prstDash val="solid"/>
           </a:ln>
         </p:spPr>
+        <p:txBody>
+          <a:bodyPr/>
+          <a:lstStyle/>
+          <a:p>
+            <a:endParaRPr lang="en-US"/>
+          </a:p>
+        </p:txBody>
       </p:sp>
       <p:sp>
         <p:nvSpPr>
@@ -1483,31 +1256,14 @@
             <a:prstDash val="solid"/>
           </a:ln>
         </p:spPr>
-      </p:sp>
-      <p:pic>
-        <p:nvPicPr>
-          <p:cNvPr id="5" name="Image 0" descr="/sessions/intelligent-clever-carson/polymathics_logo.png">    </p:cNvPr>
-          <p:cNvPicPr>
-            <a:picLocks noChangeAspect="1"/>
-          </p:cNvPicPr>
-          <p:nvPr/>
-        </p:nvPicPr>
-        <p:blipFill>
-          <a:blip r:embed="rId1"/>
-          <a:stretch>
-            <a:fillRect/>
-          </a:stretch>
-        </p:blipFill>
-        <p:spPr>
-          <a:xfrm>
-            <a:off x="2971800" y="1005840"/>
-            <a:ext cx="3200400" cy="1216152"/>
-          </a:xfrm>
-          <a:prstGeom prst="rect">
-            <a:avLst/>
-          </a:prstGeom>
-        </p:spPr>
-      </p:pic>
+        <p:txBody>
+          <a:bodyPr/>
+          <a:lstStyle/>
+          <a:p>
+            <a:endParaRPr lang="en-US"/>
+          </a:p>
+        </p:txBody>
+      </p:sp>
       <p:sp>
         <p:nvSpPr>
           <p:cNvPr id="6" name="Text 3"/>
@@ -1529,7 +1285,7 @@
           <a:bodyPr wrap="square" rtlCol="0" anchor="ctr"/>
           <a:lstStyle/>
           <a:p>
-            <a:pPr algn="ctr" indent="0" marL="0">
+            <a:pPr marL="0" indent="0" algn="ctr">
               <a:buNone/>
             </a:pPr>
             <a:r>
@@ -1571,6 +1327,13 @@
             <a:prstDash val="solid"/>
           </a:ln>
         </p:spPr>
+        <p:txBody>
+          <a:bodyPr/>
+          <a:lstStyle/>
+          <a:p>
+            <a:endParaRPr lang="en-US"/>
+          </a:p>
+        </p:txBody>
       </p:sp>
       <p:sp>
         <p:nvSpPr>
@@ -1593,7 +1356,7 @@
           <a:bodyPr wrap="square" rtlCol="0" anchor="ctr"/>
           <a:lstStyle/>
           <a:p>
-            <a:pPr algn="ctr" indent="0" marL="0">
+            <a:pPr marL="0" indent="0" algn="ctr">
               <a:buNone/>
             </a:pPr>
             <a:r>
@@ -1632,7 +1395,7 @@
           <a:bodyPr wrap="square" rtlCol="0" anchor="ctr"/>
           <a:lstStyle/>
           <a:p>
-            <a:pPr algn="ctr" indent="0" marL="0">
+            <a:pPr marL="0" indent="0" algn="ctr">
               <a:buNone/>
             </a:pPr>
             <a:r>
@@ -1671,7 +1434,7 @@
           <a:bodyPr wrap="square" rtlCol="0" anchor="ctr"/>
           <a:lstStyle/>
           <a:p>
-            <a:pPr algn="ctr" indent="0" marL="0">
+            <a:pPr marL="0" indent="0" algn="ctr">
               <a:buNone/>
             </a:pPr>
             <a:r>
@@ -1689,6 +1452,36 @@
           </a:p>
         </p:txBody>
       </p:sp>
+      <p:pic>
+        <p:nvPicPr>
+          <p:cNvPr id="14" name="Picture 13" descr="A blue and white logo&#10;&#10;AI-generated content may be incorrect.">
+            <a:extLst>
+              <a:ext uri="{FF2B5EF4-FFF2-40B4-BE49-F238E27FC236}">
+                <a16:creationId xmlns:a16="http://schemas.microsoft.com/office/drawing/2014/main" id="{AE91F655-7FDA-EF09-33D3-450606B47E62}"/>
+              </a:ext>
+            </a:extLst>
+          </p:cNvPr>
+          <p:cNvPicPr>
+            <a:picLocks noChangeAspect="1"/>
+          </p:cNvPicPr>
+          <p:nvPr/>
+        </p:nvPicPr>
+        <p:blipFill>
+          <a:blip r:embed="rId3"/>
+          <a:stretch>
+            <a:fillRect/>
+          </a:stretch>
+        </p:blipFill>
+        <p:spPr>
+          <a:xfrm>
+            <a:off x="3123268" y="507197"/>
+            <a:ext cx="2897464" cy="1373264"/>
+          </a:xfrm>
+          <a:prstGeom prst="rect">
+            <a:avLst/>
+          </a:prstGeom>
+        </p:spPr>
+      </p:pic>
     </p:spTree>
   </p:cSld>
   <p:clrMapOvr>
@@ -1705,6 +1498,7 @@
         <a:solidFill>
           <a:srgbClr val="F4F5FA"/>
         </a:solidFill>
+        <a:effectLst/>
       </p:bgPr>
     </p:bg>
     <p:spTree>
@@ -1745,6 +1539,13 @@
             <a:prstDash val="solid"/>
           </a:ln>
         </p:spPr>
+        <p:txBody>
+          <a:bodyPr/>
+          <a:lstStyle/>
+          <a:p>
+            <a:endParaRPr lang="en-US"/>
+          </a:p>
+        </p:txBody>
       </p:sp>
       <p:sp>
         <p:nvSpPr>
@@ -1770,6 +1571,13 @@
             <a:prstDash val="solid"/>
           </a:ln>
         </p:spPr>
+        <p:txBody>
+          <a:bodyPr/>
+          <a:lstStyle/>
+          <a:p>
+            <a:endParaRPr lang="en-US"/>
+          </a:p>
+        </p:txBody>
       </p:sp>
       <p:sp>
         <p:nvSpPr>
@@ -1792,7 +1600,7 @@
           <a:bodyPr wrap="square" lIns="0" tIns="0" rIns="0" bIns="0" rtlCol="0" anchor="ctr"/>
           <a:lstStyle/>
           <a:p>
-            <a:pPr indent="0" marL="0">
+            <a:pPr marL="0" indent="0">
               <a:buNone/>
             </a:pPr>
             <a:r>
@@ -1810,30 +1618,6 @@
           </a:p>
         </p:txBody>
       </p:sp>
-      <p:pic>
-        <p:nvPicPr>
-          <p:cNvPr id="5" name="Image 0" descr="/sessions/intelligent-clever-carson/polymathics_logo.png">    </p:cNvPr>
-          <p:cNvPicPr>
-            <a:picLocks noChangeAspect="1"/>
-          </p:cNvPicPr>
-          <p:nvPr/>
-        </p:nvPicPr>
-        <p:blipFill>
-          <a:blip r:embed="rId1"/>
-          <a:stretch>
-            <a:fillRect/>
-          </a:stretch>
-        </p:blipFill>
-        <p:spPr>
-          <a:xfrm>
-            <a:off x="7589520" y="91440"/>
-            <a:ext cx="1371600" cy="521208"/>
-          </a:xfrm>
-          <a:prstGeom prst="rect">
-            <a:avLst/>
-          </a:prstGeom>
-        </p:spPr>
-      </p:pic>
       <p:sp>
         <p:nvSpPr>
           <p:cNvPr id="6" name="Shape 3"/>
@@ -1858,13 +1642,20 @@
             <a:prstDash val="solid"/>
           </a:ln>
           <a:effectLst>
-            <a:outerShdw sx="100000" sy="100000" kx="0" ky="0" algn="bl" rotWithShape="0" blurRad="101600" dist="25400" dir="8100000">
+            <a:outerShdw blurRad="101600" dist="25400" dir="8100000" algn="bl" rotWithShape="0">
               <a:srgbClr val="000000">
                 <a:alpha val="8000"/>
               </a:srgbClr>
             </a:outerShdw>
           </a:effectLst>
         </p:spPr>
+        <p:txBody>
+          <a:bodyPr/>
+          <a:lstStyle/>
+          <a:p>
+            <a:endParaRPr lang="en-US"/>
+          </a:p>
+        </p:txBody>
       </p:sp>
       <p:sp>
         <p:nvSpPr>
@@ -1890,6 +1681,13 @@
             <a:prstDash val="solid"/>
           </a:ln>
         </p:spPr>
+        <p:txBody>
+          <a:bodyPr/>
+          <a:lstStyle/>
+          <a:p>
+            <a:endParaRPr lang="en-US"/>
+          </a:p>
+        </p:txBody>
       </p:sp>
       <p:sp>
         <p:nvSpPr>
@@ -1912,7 +1710,7 @@
           <a:bodyPr wrap="square" lIns="0" tIns="0" rIns="0" bIns="0" rtlCol="0" anchor="ctr"/>
           <a:lstStyle/>
           <a:p>
-            <a:pPr algn="ctr" indent="0" marL="0">
+            <a:pPr marL="0" indent="0" algn="ctr">
               <a:buNone/>
             </a:pPr>
             <a:r>
@@ -1951,7 +1749,7 @@
           <a:bodyPr wrap="square" rtlCol="0" anchor="ctr"/>
           <a:lstStyle/>
           <a:p>
-            <a:pPr indent="0" marL="0">
+            <a:pPr marL="0" indent="0">
               <a:buNone/>
             </a:pPr>
             <a:r>
@@ -1990,7 +1788,7 @@
           <a:bodyPr wrap="square" rtlCol="0" anchor="ctr"/>
           <a:lstStyle/>
           <a:p>
-            <a:pPr indent="0" marL="0">
+            <a:pPr marL="0" indent="0">
               <a:buNone/>
             </a:pPr>
             <a:r>
@@ -2032,13 +1830,20 @@
             <a:prstDash val="solid"/>
           </a:ln>
           <a:effectLst>
-            <a:outerShdw sx="100000" sy="100000" kx="0" ky="0" algn="bl" rotWithShape="0" blurRad="101600" dist="25400" dir="8100000">
+            <a:outerShdw blurRad="101600" dist="25400" dir="8100000" algn="bl" rotWithShape="0">
               <a:srgbClr val="000000">
                 <a:alpha val="8000"/>
               </a:srgbClr>
             </a:outerShdw>
           </a:effectLst>
         </p:spPr>
+        <p:txBody>
+          <a:bodyPr/>
+          <a:lstStyle/>
+          <a:p>
+            <a:endParaRPr lang="en-US"/>
+          </a:p>
+        </p:txBody>
       </p:sp>
       <p:sp>
         <p:nvSpPr>
@@ -2064,6 +1869,13 @@
             <a:prstDash val="solid"/>
           </a:ln>
         </p:spPr>
+        <p:txBody>
+          <a:bodyPr/>
+          <a:lstStyle/>
+          <a:p>
+            <a:endParaRPr lang="en-US"/>
+          </a:p>
+        </p:txBody>
       </p:sp>
       <p:sp>
         <p:nvSpPr>
@@ -2086,7 +1898,7 @@
           <a:bodyPr wrap="square" lIns="0" tIns="0" rIns="0" bIns="0" rtlCol="0" anchor="ctr"/>
           <a:lstStyle/>
           <a:p>
-            <a:pPr algn="ctr" indent="0" marL="0">
+            <a:pPr marL="0" indent="0" algn="ctr">
               <a:buNone/>
             </a:pPr>
             <a:r>
@@ -2125,7 +1937,7 @@
           <a:bodyPr wrap="square" rtlCol="0" anchor="ctr"/>
           <a:lstStyle/>
           <a:p>
-            <a:pPr indent="0" marL="0">
+            <a:pPr marL="0" indent="0">
               <a:buNone/>
             </a:pPr>
             <a:r>
@@ -2164,7 +1976,7 @@
           <a:bodyPr wrap="square" rtlCol="0" anchor="ctr"/>
           <a:lstStyle/>
           <a:p>
-            <a:pPr indent="0" marL="0">
+            <a:pPr marL="0" indent="0">
               <a:buNone/>
             </a:pPr>
             <a:r>
@@ -2206,13 +2018,20 @@
             <a:prstDash val="solid"/>
           </a:ln>
           <a:effectLst>
-            <a:outerShdw sx="100000" sy="100000" kx="0" ky="0" algn="bl" rotWithShape="0" blurRad="101600" dist="25400" dir="8100000">
+            <a:outerShdw blurRad="101600" dist="25400" dir="8100000" algn="bl" rotWithShape="0">
               <a:srgbClr val="000000">
                 <a:alpha val="8000"/>
               </a:srgbClr>
             </a:outerShdw>
           </a:effectLst>
         </p:spPr>
+        <p:txBody>
+          <a:bodyPr/>
+          <a:lstStyle/>
+          <a:p>
+            <a:endParaRPr lang="en-US"/>
+          </a:p>
+        </p:txBody>
       </p:sp>
       <p:sp>
         <p:nvSpPr>
@@ -2238,6 +2057,13 @@
             <a:prstDash val="solid"/>
           </a:ln>
         </p:spPr>
+        <p:txBody>
+          <a:bodyPr/>
+          <a:lstStyle/>
+          <a:p>
+            <a:endParaRPr lang="en-US"/>
+          </a:p>
+        </p:txBody>
       </p:sp>
       <p:sp>
         <p:nvSpPr>
@@ -2260,7 +2086,7 @@
           <a:bodyPr wrap="square" lIns="0" tIns="0" rIns="0" bIns="0" rtlCol="0" anchor="ctr"/>
           <a:lstStyle/>
           <a:p>
-            <a:pPr algn="ctr" indent="0" marL="0">
+            <a:pPr marL="0" indent="0" algn="ctr">
               <a:buNone/>
             </a:pPr>
             <a:r>
@@ -2299,7 +2125,7 @@
           <a:bodyPr wrap="square" rtlCol="0" anchor="ctr"/>
           <a:lstStyle/>
           <a:p>
-            <a:pPr indent="0" marL="0">
+            <a:pPr marL="0" indent="0">
               <a:buNone/>
             </a:pPr>
             <a:r>
@@ -2338,7 +2164,7 @@
           <a:bodyPr wrap="square" rtlCol="0" anchor="ctr"/>
           <a:lstStyle/>
           <a:p>
-            <a:pPr indent="0" marL="0">
+            <a:pPr marL="0" indent="0">
               <a:buNone/>
             </a:pPr>
             <a:r>
@@ -2380,13 +2206,20 @@
             <a:prstDash val="solid"/>
           </a:ln>
           <a:effectLst>
-            <a:outerShdw sx="100000" sy="100000" kx="0" ky="0" algn="bl" rotWithShape="0" blurRad="101600" dist="25400" dir="8100000">
+            <a:outerShdw blurRad="101600" dist="25400" dir="8100000" algn="bl" rotWithShape="0">
               <a:srgbClr val="000000">
                 <a:alpha val="8000"/>
               </a:srgbClr>
             </a:outerShdw>
           </a:effectLst>
         </p:spPr>
+        <p:txBody>
+          <a:bodyPr/>
+          <a:lstStyle/>
+          <a:p>
+            <a:endParaRPr lang="en-US"/>
+          </a:p>
+        </p:txBody>
       </p:sp>
       <p:sp>
         <p:nvSpPr>
@@ -2412,6 +2245,13 @@
             <a:prstDash val="solid"/>
           </a:ln>
         </p:spPr>
+        <p:txBody>
+          <a:bodyPr/>
+          <a:lstStyle/>
+          <a:p>
+            <a:endParaRPr lang="en-US"/>
+          </a:p>
+        </p:txBody>
       </p:sp>
       <p:sp>
         <p:nvSpPr>
@@ -2434,7 +2274,7 @@
           <a:bodyPr wrap="square" lIns="0" tIns="0" rIns="0" bIns="0" rtlCol="0" anchor="ctr"/>
           <a:lstStyle/>
           <a:p>
-            <a:pPr algn="ctr" indent="0" marL="0">
+            <a:pPr marL="0" indent="0" algn="ctr">
               <a:buNone/>
             </a:pPr>
             <a:r>
@@ -2473,7 +2313,7 @@
           <a:bodyPr wrap="square" rtlCol="0" anchor="ctr"/>
           <a:lstStyle/>
           <a:p>
-            <a:pPr indent="0" marL="0">
+            <a:pPr marL="0" indent="0">
               <a:buNone/>
             </a:pPr>
             <a:r>
@@ -2512,7 +2352,7 @@
           <a:bodyPr wrap="square" rtlCol="0" anchor="ctr"/>
           <a:lstStyle/>
           <a:p>
-            <a:pPr indent="0" marL="0">
+            <a:pPr marL="0" indent="0">
               <a:buNone/>
             </a:pPr>
             <a:r>
@@ -2554,6 +2394,13 @@
             <a:prstDash val="solid"/>
           </a:ln>
         </p:spPr>
+        <p:txBody>
+          <a:bodyPr/>
+          <a:lstStyle/>
+          <a:p>
+            <a:endParaRPr lang="en-US"/>
+          </a:p>
+        </p:txBody>
       </p:sp>
       <p:sp>
         <p:nvSpPr>
@@ -2576,7 +2423,7 @@
           <a:bodyPr wrap="square" rtlCol="0" anchor="ctr"/>
           <a:lstStyle/>
           <a:p>
-            <a:pPr algn="r" indent="0" marL="0">
+            <a:pPr marL="0" indent="0" algn="r">
               <a:buNone/>
             </a:pPr>
             <a:r>
@@ -2594,6 +2441,36 @@
           </a:p>
         </p:txBody>
       </p:sp>
+      <p:pic>
+        <p:nvPicPr>
+          <p:cNvPr id="29" name="Picture 28" descr="A blue and white logo&#10;&#10;AI-generated content may be incorrect.">
+            <a:extLst>
+              <a:ext uri="{FF2B5EF4-FFF2-40B4-BE49-F238E27FC236}">
+                <a16:creationId xmlns:a16="http://schemas.microsoft.com/office/drawing/2014/main" id="{AD9A87A0-6FDC-F09D-9200-3579F14C51B2}"/>
+              </a:ext>
+            </a:extLst>
+          </p:cNvPr>
+          <p:cNvPicPr>
+            <a:picLocks noChangeAspect="1"/>
+          </p:cNvPicPr>
+          <p:nvPr/>
+        </p:nvPicPr>
+        <p:blipFill>
+          <a:blip r:embed="rId3"/>
+          <a:stretch>
+            <a:fillRect/>
+          </a:stretch>
+        </p:blipFill>
+        <p:spPr>
+          <a:xfrm>
+            <a:off x="7152301" y="47547"/>
+            <a:ext cx="1518243" cy="719577"/>
+          </a:xfrm>
+          <a:prstGeom prst="rect">
+            <a:avLst/>
+          </a:prstGeom>
+        </p:spPr>
+      </p:pic>
     </p:spTree>
   </p:cSld>
   <p:clrMapOvr>
@@ -2610,6 +2487,7 @@
         <a:solidFill>
           <a:srgbClr val="FFFFFF"/>
         </a:solidFill>
+        <a:effectLst/>
       </p:bgPr>
     </p:bg>
     <p:spTree>
@@ -2650,6 +2528,13 @@
             <a:prstDash val="solid"/>
           </a:ln>
         </p:spPr>
+        <p:txBody>
+          <a:bodyPr/>
+          <a:lstStyle/>
+          <a:p>
+            <a:endParaRPr lang="en-US"/>
+          </a:p>
+        </p:txBody>
       </p:sp>
       <p:sp>
         <p:nvSpPr>
@@ -2675,31 +2560,14 @@
             <a:prstDash val="solid"/>
           </a:ln>
         </p:spPr>
-      </p:sp>
-      <p:pic>
-        <p:nvPicPr>
-          <p:cNvPr id="4" name="Image 0" descr="/sessions/intelligent-clever-carson/polymathics_icon_white.png">    </p:cNvPr>
-          <p:cNvPicPr>
-            <a:picLocks noChangeAspect="1"/>
-          </p:cNvPicPr>
-          <p:nvPr/>
-        </p:nvPicPr>
-        <p:blipFill>
-          <a:blip r:embed="rId1"/>
-          <a:stretch>
-            <a:fillRect/>
-          </a:stretch>
-        </p:blipFill>
-        <p:spPr>
-          <a:xfrm>
-            <a:off x="457200" y="320040"/>
-            <a:ext cx="868680" cy="868680"/>
-          </a:xfrm>
-          <a:prstGeom prst="rect">
-            <a:avLst/>
-          </a:prstGeom>
-        </p:spPr>
-      </p:pic>
+        <p:txBody>
+          <a:bodyPr/>
+          <a:lstStyle/>
+          <a:p>
+            <a:endParaRPr lang="en-US"/>
+          </a:p>
+        </p:txBody>
+      </p:sp>
       <p:sp>
         <p:nvSpPr>
           <p:cNvPr id="5" name="Text 2"/>
@@ -2721,11 +2589,11 @@
           <a:bodyPr wrap="square" rtlCol="0" anchor="ctr"/>
           <a:lstStyle/>
           <a:p>
-            <a:pPr algn="l" indent="0" marL="0">
-              <a:buNone/>
-            </a:pPr>
-            <a:r>
-              <a:rPr lang="en-US" sz="1100" b="1" spc="400" kern="0" dirty="0">
+            <a:pPr marL="0" indent="0" algn="l">
+              <a:buNone/>
+            </a:pPr>
+            <a:r>
+              <a:rPr lang="en-US" sz="1100" b="1" kern="0" spc="400" dirty="0">
                 <a:solidFill>
                   <a:srgbClr val="8080CC"/>
                 </a:solidFill>
@@ -2760,7 +2628,7 @@
           <a:bodyPr wrap="square" rtlCol="0" anchor="ctr"/>
           <a:lstStyle/>
           <a:p>
-            <a:pPr algn="l" indent="0" marL="0">
+            <a:pPr marL="0" indent="0" algn="l">
               <a:buNone/>
             </a:pPr>
             <a:r>
@@ -2799,7 +2667,7 @@
           <a:bodyPr wrap="square" rtlCol="0" anchor="ctr"/>
           <a:lstStyle/>
           <a:p>
-            <a:pPr indent="0" marL="0">
+            <a:pPr marL="0" indent="0">
               <a:buNone/>
             </a:pPr>
             <a:r>
@@ -2838,7 +2706,7 @@
           <a:bodyPr wrap="square" rtlCol="0" anchor="ctr"/>
           <a:lstStyle/>
           <a:p>
-            <a:pPr indent="0" marL="0">
+            <a:pPr marL="0" indent="0">
               <a:buNone/>
             </a:pPr>
             <a:r>
@@ -2880,6 +2748,13 @@
             <a:prstDash val="solid"/>
           </a:ln>
         </p:spPr>
+        <p:txBody>
+          <a:bodyPr/>
+          <a:lstStyle/>
+          <a:p>
+            <a:endParaRPr lang="en-US"/>
+          </a:p>
+        </p:txBody>
       </p:sp>
       <p:sp>
         <p:nvSpPr>
@@ -2902,7 +2777,7 @@
           <a:bodyPr wrap="square" rtlCol="0" anchor="ctr"/>
           <a:lstStyle/>
           <a:p>
-            <a:pPr indent="0" marL="0">
+            <a:pPr marL="0" indent="0">
               <a:buNone/>
             </a:pPr>
             <a:r>
@@ -2944,6 +2819,13 @@
             <a:prstDash val="solid"/>
           </a:ln>
         </p:spPr>
+        <p:txBody>
+          <a:bodyPr/>
+          <a:lstStyle/>
+          <a:p>
+            <a:endParaRPr lang="en-US"/>
+          </a:p>
+        </p:txBody>
       </p:sp>
       <p:sp>
         <p:nvSpPr>
@@ -2966,7 +2848,7 @@
           <a:bodyPr wrap="square" rtlCol="0" anchor="ctr"/>
           <a:lstStyle/>
           <a:p>
-            <a:pPr algn="r" indent="0" marL="0">
+            <a:pPr marL="0" indent="0" algn="r">
               <a:buNone/>
             </a:pPr>
             <a:r>
@@ -2984,6 +2866,36 @@
           </a:p>
         </p:txBody>
       </p:sp>
+      <p:pic>
+        <p:nvPicPr>
+          <p:cNvPr id="14" name="Picture 13" descr="A blue and black logo&#10;&#10;AI-generated content may be incorrect.">
+            <a:extLst>
+              <a:ext uri="{FF2B5EF4-FFF2-40B4-BE49-F238E27FC236}">
+                <a16:creationId xmlns:a16="http://schemas.microsoft.com/office/drawing/2014/main" id="{066683B4-8D65-612A-6C91-FB0EFA8DF1A7}"/>
+              </a:ext>
+            </a:extLst>
+          </p:cNvPr>
+          <p:cNvPicPr>
+            <a:picLocks noChangeAspect="1"/>
+          </p:cNvPicPr>
+          <p:nvPr/>
+        </p:nvPicPr>
+        <p:blipFill>
+          <a:blip r:embed="rId3"/>
+          <a:stretch>
+            <a:fillRect/>
+          </a:stretch>
+        </p:blipFill>
+        <p:spPr>
+          <a:xfrm>
+            <a:off x="416880" y="365760"/>
+            <a:ext cx="789112" cy="736600"/>
+          </a:xfrm>
+          <a:prstGeom prst="rect">
+            <a:avLst/>
+          </a:prstGeom>
+        </p:spPr>
+      </p:pic>
     </p:spTree>
   </p:cSld>
   <p:clrMapOvr>
@@ -3000,6 +2912,7 @@
         <a:solidFill>
           <a:srgbClr val="F4F5FA"/>
         </a:solidFill>
+        <a:effectLst/>
       </p:bgPr>
     </p:bg>
     <p:spTree>
@@ -3040,6 +2953,13 @@
             <a:prstDash val="solid"/>
           </a:ln>
         </p:spPr>
+        <p:txBody>
+          <a:bodyPr/>
+          <a:lstStyle/>
+          <a:p>
+            <a:endParaRPr lang="en-US"/>
+          </a:p>
+        </p:txBody>
       </p:sp>
       <p:sp>
         <p:nvSpPr>
@@ -3065,6 +2985,13 @@
             <a:prstDash val="solid"/>
           </a:ln>
         </p:spPr>
+        <p:txBody>
+          <a:bodyPr/>
+          <a:lstStyle/>
+          <a:p>
+            <a:endParaRPr lang="en-US"/>
+          </a:p>
+        </p:txBody>
       </p:sp>
       <p:sp>
         <p:nvSpPr>
@@ -3087,7 +3014,7 @@
           <a:bodyPr wrap="square" lIns="0" tIns="0" rIns="0" bIns="0" rtlCol="0" anchor="ctr"/>
           <a:lstStyle/>
           <a:p>
-            <a:pPr indent="0" marL="0">
+            <a:pPr marL="0" indent="0">
               <a:buNone/>
             </a:pPr>
             <a:r>
@@ -3105,30 +3032,6 @@
           </a:p>
         </p:txBody>
       </p:sp>
-      <p:pic>
-        <p:nvPicPr>
-          <p:cNvPr id="5" name="Image 0" descr="/sessions/intelligent-clever-carson/polymathics_logo.png">    </p:cNvPr>
-          <p:cNvPicPr>
-            <a:picLocks noChangeAspect="1"/>
-          </p:cNvPicPr>
-          <p:nvPr/>
-        </p:nvPicPr>
-        <p:blipFill>
-          <a:blip r:embed="rId1"/>
-          <a:stretch>
-            <a:fillRect/>
-          </a:stretch>
-        </p:blipFill>
-        <p:spPr>
-          <a:xfrm>
-            <a:off x="7818120" y="109728"/>
-            <a:ext cx="1188720" cy="451714"/>
-          </a:xfrm>
-          <a:prstGeom prst="rect">
-            <a:avLst/>
-          </a:prstGeom>
-        </p:spPr>
-      </p:pic>
       <p:sp>
         <p:nvSpPr>
           <p:cNvPr id="6" name="Shape 3"/>
@@ -3153,13 +3056,20 @@
             <a:prstDash val="solid"/>
           </a:ln>
           <a:effectLst>
-            <a:outerShdw sx="100000" sy="100000" kx="0" ky="0" algn="bl" rotWithShape="0" blurRad="76200" dist="25400" dir="8100000">
+            <a:outerShdw blurRad="76200" dist="25400" dir="8100000" algn="bl" rotWithShape="0">
               <a:srgbClr val="000000">
                 <a:alpha val="7000"/>
               </a:srgbClr>
             </a:outerShdw>
           </a:effectLst>
         </p:spPr>
+        <p:txBody>
+          <a:bodyPr/>
+          <a:lstStyle/>
+          <a:p>
+            <a:endParaRPr lang="en-US"/>
+          </a:p>
+        </p:txBody>
       </p:sp>
       <p:sp>
         <p:nvSpPr>
@@ -3185,6 +3095,13 @@
             <a:prstDash val="solid"/>
           </a:ln>
         </p:spPr>
+        <p:txBody>
+          <a:bodyPr/>
+          <a:lstStyle/>
+          <a:p>
+            <a:endParaRPr lang="en-US"/>
+          </a:p>
+        </p:txBody>
       </p:sp>
       <p:sp>
         <p:nvSpPr>
@@ -3207,7 +3124,7 @@
           <a:bodyPr wrap="square" rtlCol="0" anchor="ctr"/>
           <a:lstStyle/>
           <a:p>
-            <a:pPr indent="0" marL="0">
+            <a:pPr marL="0" indent="0">
               <a:buNone/>
             </a:pPr>
             <a:r>
@@ -3246,7 +3163,7 @@
           <a:bodyPr wrap="square" rtlCol="0" anchor="ctr"/>
           <a:lstStyle/>
           <a:p>
-            <a:pPr indent="0" marL="0">
+            <a:pPr marL="0" indent="0">
               <a:buNone/>
             </a:pPr>
             <a:r>
@@ -3263,13 +3180,13 @@
             <a:endParaRPr lang="en-US" sz="1300" dirty="0"/>
           </a:p>
           <a:p>
-            <a:pPr indent="0" marL="0">
+            <a:pPr marL="0" indent="0">
               <a:buNone/>
             </a:pPr>
             <a:endParaRPr lang="en-US" sz="1300" dirty="0"/>
           </a:p>
           <a:p>
-            <a:pPr indent="0" marL="0">
+            <a:pPr marL="0" indent="0">
               <a:buNone/>
             </a:pPr>
             <a:r>
@@ -3286,13 +3203,13 @@
             <a:endParaRPr lang="en-US" sz="1300" dirty="0"/>
           </a:p>
           <a:p>
-            <a:pPr indent="0" marL="0">
+            <a:pPr marL="0" indent="0">
               <a:buNone/>
             </a:pPr>
             <a:endParaRPr lang="en-US" sz="1300" dirty="0"/>
           </a:p>
           <a:p>
-            <a:pPr indent="0" marL="0">
+            <a:pPr marL="0" indent="0">
               <a:buNone/>
             </a:pPr>
             <a:r>
@@ -3309,13 +3226,13 @@
             <a:endParaRPr lang="en-US" sz="1300" dirty="0"/>
           </a:p>
           <a:p>
-            <a:pPr indent="0" marL="0">
+            <a:pPr marL="0" indent="0">
               <a:buNone/>
             </a:pPr>
             <a:endParaRPr lang="en-US" sz="1300" dirty="0"/>
           </a:p>
           <a:p>
-            <a:pPr indent="0" marL="0">
+            <a:pPr marL="0" indent="0">
               <a:buNone/>
             </a:pPr>
             <a:r>
@@ -3357,13 +3274,20 @@
             <a:prstDash val="solid"/>
           </a:ln>
           <a:effectLst>
-            <a:outerShdw sx="100000" sy="100000" kx="0" ky="0" algn="bl" rotWithShape="0" blurRad="76200" dist="25400" dir="8100000">
+            <a:outerShdw blurRad="76200" dist="25400" dir="8100000" algn="bl" rotWithShape="0">
               <a:srgbClr val="000000">
                 <a:alpha val="7000"/>
               </a:srgbClr>
             </a:outerShdw>
           </a:effectLst>
         </p:spPr>
+        <p:txBody>
+          <a:bodyPr/>
+          <a:lstStyle/>
+          <a:p>
+            <a:endParaRPr lang="en-US"/>
+          </a:p>
+        </p:txBody>
       </p:sp>
       <p:sp>
         <p:nvSpPr>
@@ -3389,6 +3313,13 @@
             <a:prstDash val="solid"/>
           </a:ln>
         </p:spPr>
+        <p:txBody>
+          <a:bodyPr/>
+          <a:lstStyle/>
+          <a:p>
+            <a:endParaRPr lang="en-US"/>
+          </a:p>
+        </p:txBody>
       </p:sp>
       <p:sp>
         <p:nvSpPr>
@@ -3411,7 +3342,7 @@
           <a:bodyPr wrap="square" rtlCol="0" anchor="ctr"/>
           <a:lstStyle/>
           <a:p>
-            <a:pPr indent="0" marL="0">
+            <a:pPr marL="0" indent="0">
               <a:buNone/>
             </a:pPr>
             <a:r>
@@ -3450,7 +3381,7 @@
           <a:bodyPr wrap="square" rtlCol="0" anchor="ctr"/>
           <a:lstStyle/>
           <a:p>
-            <a:pPr indent="0" marL="0">
+            <a:pPr marL="0" indent="0">
               <a:buNone/>
             </a:pPr>
             <a:r>
@@ -3492,6 +3423,13 @@
             <a:prstDash val="solid"/>
           </a:ln>
         </p:spPr>
+        <p:txBody>
+          <a:bodyPr/>
+          <a:lstStyle/>
+          <a:p>
+            <a:endParaRPr lang="en-US"/>
+          </a:p>
+        </p:txBody>
       </p:sp>
       <p:sp>
         <p:nvSpPr>
@@ -3514,7 +3452,7 @@
           <a:bodyPr wrap="square" rtlCol="0" anchor="ctr"/>
           <a:lstStyle/>
           <a:p>
-            <a:pPr algn="r" indent="0" marL="0">
+            <a:pPr marL="0" indent="0" algn="r">
               <a:buNone/>
             </a:pPr>
             <a:r>
@@ -3532,6 +3470,36 @@
           </a:p>
         </p:txBody>
       </p:sp>
+      <p:pic>
+        <p:nvPicPr>
+          <p:cNvPr id="16" name="Picture 15" descr="A blue and white logo&#10;&#10;AI-generated content may be incorrect.">
+            <a:extLst>
+              <a:ext uri="{FF2B5EF4-FFF2-40B4-BE49-F238E27FC236}">
+                <a16:creationId xmlns:a16="http://schemas.microsoft.com/office/drawing/2014/main" id="{C46742D4-77AD-F210-E02F-2BC85A2A7ED2}"/>
+              </a:ext>
+            </a:extLst>
+          </p:cNvPr>
+          <p:cNvPicPr>
+            <a:picLocks noChangeAspect="1"/>
+          </p:cNvPicPr>
+          <p:nvPr/>
+        </p:nvPicPr>
+        <p:blipFill>
+          <a:blip r:embed="rId3"/>
+          <a:stretch>
+            <a:fillRect/>
+          </a:stretch>
+        </p:blipFill>
+        <p:spPr>
+          <a:xfrm>
+            <a:off x="7152301" y="47547"/>
+            <a:ext cx="1518243" cy="719577"/>
+          </a:xfrm>
+          <a:prstGeom prst="rect">
+            <a:avLst/>
+          </a:prstGeom>
+        </p:spPr>
+      </p:pic>
     </p:spTree>
   </p:cSld>
   <p:clrMapOvr>
@@ -3548,6 +3516,7 @@
         <a:solidFill>
           <a:srgbClr val="0D0D78"/>
         </a:solidFill>
+        <a:effectLst/>
       </p:bgPr>
     </p:bg>
     <p:spTree>
@@ -3588,6 +3557,13 @@
             <a:prstDash val="solid"/>
           </a:ln>
         </p:spPr>
+        <p:txBody>
+          <a:bodyPr/>
+          <a:lstStyle/>
+          <a:p>
+            <a:endParaRPr lang="en-US"/>
+          </a:p>
+        </p:txBody>
       </p:sp>
       <p:sp>
         <p:nvSpPr>
@@ -3610,7 +3586,7 @@
           <a:bodyPr wrap="square" rtlCol="0" anchor="ctr"/>
           <a:lstStyle/>
           <a:p>
-            <a:pPr algn="ctr" indent="0" marL="0">
+            <a:pPr marL="0" indent="0" algn="ctr">
               <a:buNone/>
             </a:pPr>
             <a:r>
@@ -3649,7 +3625,7 @@
           <a:bodyPr wrap="square" rtlCol="0" anchor="ctr"/>
           <a:lstStyle/>
           <a:p>
-            <a:pPr algn="ctr" indent="0" marL="0">
+            <a:pPr marL="0" indent="0" algn="ctr">
               <a:buNone/>
             </a:pPr>
             <a:r>
@@ -3691,13 +3667,20 @@
             <a:prstDash val="solid"/>
           </a:ln>
           <a:effectLst>
-            <a:outerShdw sx="100000" sy="100000" kx="0" ky="0" algn="bl" rotWithShape="0" blurRad="152400" dist="38100" dir="8100000">
+            <a:outerShdw blurRad="152400" dist="38100" dir="8100000" algn="bl" rotWithShape="0">
               <a:srgbClr val="000000">
                 <a:alpha val="25000"/>
               </a:srgbClr>
             </a:outerShdw>
           </a:effectLst>
         </p:spPr>
+        <p:txBody>
+          <a:bodyPr/>
+          <a:lstStyle/>
+          <a:p>
+            <a:endParaRPr lang="en-US"/>
+          </a:p>
+        </p:txBody>
       </p:sp>
       <p:sp>
         <p:nvSpPr>
@@ -3723,6 +3706,13 @@
             <a:prstDash val="solid"/>
           </a:ln>
         </p:spPr>
+        <p:txBody>
+          <a:bodyPr/>
+          <a:lstStyle/>
+          <a:p>
+            <a:endParaRPr lang="en-US"/>
+          </a:p>
+        </p:txBody>
       </p:sp>
       <p:sp>
         <p:nvSpPr>
@@ -3745,7 +3735,7 @@
           <a:bodyPr wrap="square" rtlCol="0" anchor="ctr"/>
           <a:lstStyle/>
           <a:p>
-            <a:pPr algn="ctr" indent="0" marL="0">
+            <a:pPr marL="0" indent="0" algn="ctr">
               <a:buNone/>
             </a:pPr>
             <a:r>
@@ -3784,7 +3774,7 @@
           <a:bodyPr wrap="square" rtlCol="0" anchor="ctr"/>
           <a:lstStyle/>
           <a:p>
-            <a:pPr algn="ctr" indent="0" marL="0">
+            <a:pPr marL="0" indent="0" algn="ctr">
               <a:buNone/>
             </a:pPr>
             <a:r>
@@ -3823,7 +3813,7 @@
           <a:bodyPr wrap="square" rtlCol="0" anchor="ctr"/>
           <a:lstStyle/>
           <a:p>
-            <a:pPr algn="ctr" indent="0" marL="0">
+            <a:pPr marL="0" indent="0" algn="ctr">
               <a:buNone/>
             </a:pPr>
             <a:r>
@@ -3865,13 +3855,20 @@
             <a:prstDash val="solid"/>
           </a:ln>
           <a:effectLst>
-            <a:outerShdw sx="100000" sy="100000" kx="0" ky="0" algn="bl" rotWithShape="0" blurRad="152400" dist="38100" dir="8100000">
+            <a:outerShdw blurRad="152400" dist="38100" dir="8100000" algn="bl" rotWithShape="0">
               <a:srgbClr val="000000">
                 <a:alpha val="25000"/>
               </a:srgbClr>
             </a:outerShdw>
           </a:effectLst>
         </p:spPr>
+        <p:txBody>
+          <a:bodyPr/>
+          <a:lstStyle/>
+          <a:p>
+            <a:endParaRPr lang="en-US"/>
+          </a:p>
+        </p:txBody>
       </p:sp>
       <p:sp>
         <p:nvSpPr>
@@ -3897,6 +3894,13 @@
             <a:prstDash val="solid"/>
           </a:ln>
         </p:spPr>
+        <p:txBody>
+          <a:bodyPr/>
+          <a:lstStyle/>
+          <a:p>
+            <a:endParaRPr lang="en-US"/>
+          </a:p>
+        </p:txBody>
       </p:sp>
       <p:sp>
         <p:nvSpPr>
@@ -3919,7 +3923,7 @@
           <a:bodyPr wrap="square" rtlCol="0" anchor="ctr"/>
           <a:lstStyle/>
           <a:p>
-            <a:pPr algn="ctr" indent="0" marL="0">
+            <a:pPr marL="0" indent="0" algn="ctr">
               <a:buNone/>
             </a:pPr>
             <a:r>
@@ -3958,7 +3962,7 @@
           <a:bodyPr wrap="square" rtlCol="0" anchor="ctr"/>
           <a:lstStyle/>
           <a:p>
-            <a:pPr algn="ctr" indent="0" marL="0">
+            <a:pPr marL="0" indent="0" algn="ctr">
               <a:buNone/>
             </a:pPr>
             <a:r>
@@ -3997,7 +4001,7 @@
           <a:bodyPr wrap="square" rtlCol="0" anchor="ctr"/>
           <a:lstStyle/>
           <a:p>
-            <a:pPr algn="ctr" indent="0" marL="0">
+            <a:pPr marL="0" indent="0" algn="ctr">
               <a:buNone/>
             </a:pPr>
             <a:r>
@@ -4039,13 +4043,20 @@
             <a:prstDash val="solid"/>
           </a:ln>
           <a:effectLst>
-            <a:outerShdw sx="100000" sy="100000" kx="0" ky="0" algn="bl" rotWithShape="0" blurRad="152400" dist="38100" dir="8100000">
+            <a:outerShdw blurRad="152400" dist="38100" dir="8100000" algn="bl" rotWithShape="0">
               <a:srgbClr val="000000">
                 <a:alpha val="25000"/>
               </a:srgbClr>
             </a:outerShdw>
           </a:effectLst>
         </p:spPr>
+        <p:txBody>
+          <a:bodyPr/>
+          <a:lstStyle/>
+          <a:p>
+            <a:endParaRPr lang="en-US"/>
+          </a:p>
+        </p:txBody>
       </p:sp>
       <p:sp>
         <p:nvSpPr>
@@ -4071,6 +4082,13 @@
             <a:prstDash val="solid"/>
           </a:ln>
         </p:spPr>
+        <p:txBody>
+          <a:bodyPr/>
+          <a:lstStyle/>
+          <a:p>
+            <a:endParaRPr lang="en-US"/>
+          </a:p>
+        </p:txBody>
       </p:sp>
       <p:sp>
         <p:nvSpPr>
@@ -4093,7 +4111,7 @@
           <a:bodyPr wrap="square" rtlCol="0" anchor="ctr"/>
           <a:lstStyle/>
           <a:p>
-            <a:pPr algn="ctr" indent="0" marL="0">
+            <a:pPr marL="0" indent="0" algn="ctr">
               <a:buNone/>
             </a:pPr>
             <a:r>
@@ -4132,7 +4150,7 @@
           <a:bodyPr wrap="square" rtlCol="0" anchor="ctr"/>
           <a:lstStyle/>
           <a:p>
-            <a:pPr algn="ctr" indent="0" marL="0">
+            <a:pPr marL="0" indent="0" algn="ctr">
               <a:buNone/>
             </a:pPr>
             <a:r>
@@ -4171,7 +4189,7 @@
           <a:bodyPr wrap="square" rtlCol="0" anchor="ctr"/>
           <a:lstStyle/>
           <a:p>
-            <a:pPr algn="ctr" indent="0" marL="0">
+            <a:pPr marL="0" indent="0" algn="ctr">
               <a:buNone/>
             </a:pPr>
             <a:r>
@@ -4213,6 +4231,13 @@
             <a:prstDash val="solid"/>
           </a:ln>
         </p:spPr>
+        <p:txBody>
+          <a:bodyPr/>
+          <a:lstStyle/>
+          <a:p>
+            <a:endParaRPr lang="en-US"/>
+          </a:p>
+        </p:txBody>
       </p:sp>
       <p:sp>
         <p:nvSpPr>
@@ -4235,7 +4260,7 @@
           <a:bodyPr wrap="square" rtlCol="0" anchor="ctr"/>
           <a:lstStyle/>
           <a:p>
-            <a:pPr algn="r" indent="0" marL="0">
+            <a:pPr marL="0" indent="0" algn="r">
               <a:buNone/>
             </a:pPr>
             <a:r>
@@ -4269,6 +4294,7 @@
         <a:solidFill>
           <a:srgbClr val="F4F5FA"/>
         </a:solidFill>
+        <a:effectLst/>
       </p:bgPr>
     </p:bg>
     <p:spTree>
@@ -4309,6 +4335,13 @@
             <a:prstDash val="solid"/>
           </a:ln>
         </p:spPr>
+        <p:txBody>
+          <a:bodyPr/>
+          <a:lstStyle/>
+          <a:p>
+            <a:endParaRPr lang="en-US"/>
+          </a:p>
+        </p:txBody>
       </p:sp>
       <p:sp>
         <p:nvSpPr>
@@ -4334,6 +4367,13 @@
             <a:prstDash val="solid"/>
           </a:ln>
         </p:spPr>
+        <p:txBody>
+          <a:bodyPr/>
+          <a:lstStyle/>
+          <a:p>
+            <a:endParaRPr lang="en-US"/>
+          </a:p>
+        </p:txBody>
       </p:sp>
       <p:sp>
         <p:nvSpPr>
@@ -4356,7 +4396,7 @@
           <a:bodyPr wrap="square" lIns="0" tIns="0" rIns="0" bIns="0" rtlCol="0" anchor="ctr"/>
           <a:lstStyle/>
           <a:p>
-            <a:pPr indent="0" marL="0">
+            <a:pPr marL="0" indent="0">
               <a:buNone/>
             </a:pPr>
             <a:r>
@@ -4374,30 +4414,6 @@
           </a:p>
         </p:txBody>
       </p:sp>
-      <p:pic>
-        <p:nvPicPr>
-          <p:cNvPr id="5" name="Image 0" descr="/sessions/intelligent-clever-carson/polymathics_logo.png">    </p:cNvPr>
-          <p:cNvPicPr>
-            <a:picLocks noChangeAspect="1"/>
-          </p:cNvPicPr>
-          <p:nvPr/>
-        </p:nvPicPr>
-        <p:blipFill>
-          <a:blip r:embed="rId1"/>
-          <a:stretch>
-            <a:fillRect/>
-          </a:stretch>
-        </p:blipFill>
-        <p:spPr>
-          <a:xfrm>
-            <a:off x="7818120" y="109728"/>
-            <a:ext cx="1188720" cy="451714"/>
-          </a:xfrm>
-          <a:prstGeom prst="rect">
-            <a:avLst/>
-          </a:prstGeom>
-        </p:spPr>
-      </p:pic>
       <p:sp>
         <p:nvSpPr>
           <p:cNvPr id="6" name="Shape 3"/>
@@ -4422,13 +4438,20 @@
             <a:prstDash val="solid"/>
           </a:ln>
           <a:effectLst>
-            <a:outerShdw sx="100000" sy="100000" kx="0" ky="0" algn="bl" rotWithShape="0" blurRad="76200" dist="25400" dir="8100000">
+            <a:outerShdw blurRad="76200" dist="25400" dir="8100000" algn="bl" rotWithShape="0">
               <a:srgbClr val="000000">
                 <a:alpha val="7000"/>
               </a:srgbClr>
             </a:outerShdw>
           </a:effectLst>
         </p:spPr>
+        <p:txBody>
+          <a:bodyPr/>
+          <a:lstStyle/>
+          <a:p>
+            <a:endParaRPr lang="en-US"/>
+          </a:p>
+        </p:txBody>
       </p:sp>
       <p:sp>
         <p:nvSpPr>
@@ -4454,6 +4477,13 @@
             <a:prstDash val="solid"/>
           </a:ln>
         </p:spPr>
+        <p:txBody>
+          <a:bodyPr/>
+          <a:lstStyle/>
+          <a:p>
+            <a:endParaRPr lang="en-US"/>
+          </a:p>
+        </p:txBody>
       </p:sp>
       <p:sp>
         <p:nvSpPr>
@@ -4476,7 +4506,7 @@
           <a:bodyPr wrap="square" rtlCol="0" anchor="ctr"/>
           <a:lstStyle/>
           <a:p>
-            <a:pPr indent="0" marL="0">
+            <a:pPr marL="0" indent="0">
               <a:buNone/>
             </a:pPr>
             <a:r>
@@ -4515,7 +4545,7 @@
           <a:bodyPr wrap="square" rtlCol="0" anchor="ctr"/>
           <a:lstStyle/>
           <a:p>
-            <a:pPr indent="0" marL="0">
+            <a:pPr marL="0" indent="0">
               <a:buNone/>
             </a:pPr>
             <a:r>
@@ -4532,13 +4562,13 @@
             <a:endParaRPr lang="en-US" sz="1400" dirty="0"/>
           </a:p>
           <a:p>
-            <a:pPr indent="0" marL="0">
+            <a:pPr marL="0" indent="0">
               <a:buNone/>
             </a:pPr>
             <a:endParaRPr lang="en-US" sz="1400" dirty="0"/>
           </a:p>
           <a:p>
-            <a:pPr indent="0" marL="0">
+            <a:pPr marL="0" indent="0">
               <a:buNone/>
             </a:pPr>
             <a:r>
@@ -4555,13 +4585,13 @@
             <a:endParaRPr lang="en-US" sz="1400" dirty="0"/>
           </a:p>
           <a:p>
-            <a:pPr indent="0" marL="0">
+            <a:pPr marL="0" indent="0">
               <a:buNone/>
             </a:pPr>
             <a:endParaRPr lang="en-US" sz="1400" dirty="0"/>
           </a:p>
           <a:p>
-            <a:pPr indent="0" marL="0">
+            <a:pPr marL="0" indent="0">
               <a:buNone/>
             </a:pPr>
             <a:r>
@@ -4578,13 +4608,13 @@
             <a:endParaRPr lang="en-US" sz="1400" dirty="0"/>
           </a:p>
           <a:p>
-            <a:pPr indent="0" marL="0">
+            <a:pPr marL="0" indent="0">
               <a:buNone/>
             </a:pPr>
             <a:endParaRPr lang="en-US" sz="1400" dirty="0"/>
           </a:p>
           <a:p>
-            <a:pPr indent="0" marL="0">
+            <a:pPr marL="0" indent="0">
               <a:buNone/>
             </a:pPr>
             <a:r>
@@ -4626,6 +4656,13 @@
             <a:prstDash val="solid"/>
           </a:ln>
         </p:spPr>
+        <p:txBody>
+          <a:bodyPr/>
+          <a:lstStyle/>
+          <a:p>
+            <a:endParaRPr lang="en-US"/>
+          </a:p>
+        </p:txBody>
       </p:sp>
       <p:sp>
         <p:nvSpPr>
@@ -4648,7 +4685,7 @@
           <a:bodyPr wrap="square" rtlCol="0" anchor="ctr"/>
           <a:lstStyle/>
           <a:p>
-            <a:pPr algn="r" indent="0" marL="0">
+            <a:pPr marL="0" indent="0" algn="r">
               <a:buNone/>
             </a:pPr>
             <a:r>
@@ -4666,6 +4703,36 @@
           </a:p>
         </p:txBody>
       </p:sp>
+      <p:pic>
+        <p:nvPicPr>
+          <p:cNvPr id="12" name="Picture 11" descr="A blue and white logo&#10;&#10;AI-generated content may be incorrect.">
+            <a:extLst>
+              <a:ext uri="{FF2B5EF4-FFF2-40B4-BE49-F238E27FC236}">
+                <a16:creationId xmlns:a16="http://schemas.microsoft.com/office/drawing/2014/main" id="{F373067A-860C-201F-359A-33A986C01317}"/>
+              </a:ext>
+            </a:extLst>
+          </p:cNvPr>
+          <p:cNvPicPr>
+            <a:picLocks noChangeAspect="1"/>
+          </p:cNvPicPr>
+          <p:nvPr/>
+        </p:nvPicPr>
+        <p:blipFill>
+          <a:blip r:embed="rId3"/>
+          <a:stretch>
+            <a:fillRect/>
+          </a:stretch>
+        </p:blipFill>
+        <p:spPr>
+          <a:xfrm>
+            <a:off x="7152301" y="47547"/>
+            <a:ext cx="1518243" cy="719577"/>
+          </a:xfrm>
+          <a:prstGeom prst="rect">
+            <a:avLst/>
+          </a:prstGeom>
+        </p:spPr>
+      </p:pic>
     </p:spTree>
   </p:cSld>
   <p:clrMapOvr>
@@ -4682,6 +4749,7 @@
         <a:solidFill>
           <a:srgbClr val="0D0D78"/>
         </a:solidFill>
+        <a:effectLst/>
       </p:bgPr>
     </p:bg>
     <p:spTree>
@@ -4722,6 +4790,13 @@
             <a:prstDash val="solid"/>
           </a:ln>
         </p:spPr>
+        <p:txBody>
+          <a:bodyPr/>
+          <a:lstStyle/>
+          <a:p>
+            <a:endParaRPr lang="en-US"/>
+          </a:p>
+        </p:txBody>
       </p:sp>
       <p:sp>
         <p:nvSpPr>
@@ -4747,31 +4822,14 @@
             <a:prstDash val="solid"/>
           </a:ln>
         </p:spPr>
-      </p:sp>
-      <p:pic>
-        <p:nvPicPr>
-          <p:cNvPr id="4" name="Image 0" descr="/sessions/intelligent-clever-carson/polymathics_logo.png">    </p:cNvPr>
-          <p:cNvPicPr>
-            <a:picLocks noChangeAspect="1"/>
-          </p:cNvPicPr>
-          <p:nvPr/>
-        </p:nvPicPr>
-        <p:blipFill>
-          <a:blip r:embed="rId1"/>
-          <a:stretch>
-            <a:fillRect/>
-          </a:stretch>
-        </p:blipFill>
-        <p:spPr>
-          <a:xfrm>
-            <a:off x="3108960" y="457200"/>
-            <a:ext cx="2926080" cy="1111910"/>
-          </a:xfrm>
-          <a:prstGeom prst="rect">
-            <a:avLst/>
-          </a:prstGeom>
-        </p:spPr>
-      </p:pic>
+        <p:txBody>
+          <a:bodyPr/>
+          <a:lstStyle/>
+          <a:p>
+            <a:endParaRPr lang="en-US"/>
+          </a:p>
+        </p:txBody>
+      </p:sp>
       <p:sp>
         <p:nvSpPr>
           <p:cNvPr id="5" name="Text 2"/>
@@ -4793,7 +4851,7 @@
           <a:bodyPr wrap="square" rtlCol="0" anchor="ctr"/>
           <a:lstStyle/>
           <a:p>
-            <a:pPr algn="ctr" indent="0" marL="0">
+            <a:pPr marL="0" indent="0" algn="ctr">
               <a:buNone/>
             </a:pPr>
             <a:r>
@@ -4835,6 +4893,13 @@
             <a:prstDash val="solid"/>
           </a:ln>
         </p:spPr>
+        <p:txBody>
+          <a:bodyPr/>
+          <a:lstStyle/>
+          <a:p>
+            <a:endParaRPr lang="en-US"/>
+          </a:p>
+        </p:txBody>
       </p:sp>
       <p:sp>
         <p:nvSpPr>
@@ -4857,7 +4922,7 @@
           <a:bodyPr wrap="square" rtlCol="0" anchor="ctr"/>
           <a:lstStyle/>
           <a:p>
-            <a:pPr algn="ctr" indent="0" marL="0">
+            <a:pPr marL="0" indent="0" algn="ctr">
               <a:buNone/>
             </a:pPr>
             <a:r>
@@ -4896,7 +4961,7 @@
           <a:bodyPr wrap="square" rtlCol="0" anchor="ctr"/>
           <a:lstStyle/>
           <a:p>
-            <a:pPr algn="ctr" indent="0" marL="0">
+            <a:pPr marL="0" indent="0" algn="ctr">
               <a:buNone/>
             </a:pPr>
             <a:r>
@@ -4908,7 +4973,29 @@
                 <a:ea typeface="Calibri" pitchFamily="34" charset="-122"/>
                 <a:cs typeface="Calibri" pitchFamily="34" charset="-120"/>
               </a:rPr>
-              <a:t>[Your Name]  |  [email@polymathics.ai]  |  [Phone Number]</a:t>
+              <a:t>Dag Farias  |  </a:t>
+            </a:r>
+            <a:r>
+              <a:rPr lang="en-US" sz="1400" dirty="0" err="1">
+                <a:solidFill>
+                  <a:srgbClr val="C8C8EE"/>
+                </a:solidFill>
+                <a:latin typeface="Calibri" pitchFamily="34" charset="0"/>
+                <a:ea typeface="Calibri" pitchFamily="34" charset="-122"/>
+                <a:cs typeface="Calibri" pitchFamily="34" charset="-120"/>
+              </a:rPr>
+              <a:t>dagfarias@polymathicsai.com</a:t>
+            </a:r>
+            <a:r>
+              <a:rPr lang="en-US" sz="1400" dirty="0">
+                <a:solidFill>
+                  <a:srgbClr val="C8C8EE"/>
+                </a:solidFill>
+                <a:latin typeface="Calibri" pitchFamily="34" charset="0"/>
+                <a:ea typeface="Calibri" pitchFamily="34" charset="-122"/>
+                <a:cs typeface="Calibri" pitchFamily="34" charset="-120"/>
+              </a:rPr>
+              <a:t>  |  917-916-5299</a:t>
             </a:r>
             <a:endParaRPr lang="en-US" sz="1400" dirty="0"/>
           </a:p>
@@ -4935,11 +5022,11 @@
           <a:bodyPr wrap="square" rtlCol="0" anchor="ctr"/>
           <a:lstStyle/>
           <a:p>
-            <a:pPr algn="ctr" indent="0" marL="0">
-              <a:buNone/>
-            </a:pPr>
-            <a:r>
-              <a:rPr lang="en-US" sz="1400" b="1" dirty="0">
+            <a:pPr marL="0" indent="0" algn="ctr">
+              <a:buNone/>
+            </a:pPr>
+            <a:r>
+              <a:rPr lang="en-US" sz="1400" b="1" dirty="0" err="1">
                 <a:solidFill>
                   <a:srgbClr val="8080CC"/>
                 </a:solidFill>
@@ -4947,7 +5034,7 @@
                 <a:ea typeface="Calibri" pitchFamily="34" charset="-122"/>
                 <a:cs typeface="Calibri" pitchFamily="34" charset="-120"/>
               </a:rPr>
-              <a:t>www.polymathics.ai</a:t>
+              <a:t>www.polymathicsai.com</a:t>
             </a:r>
             <a:endParaRPr lang="en-US" sz="1400" dirty="0"/>
           </a:p>
@@ -4977,6 +5064,13 @@
             <a:prstDash val="solid"/>
           </a:ln>
         </p:spPr>
+        <p:txBody>
+          <a:bodyPr/>
+          <a:lstStyle/>
+          <a:p>
+            <a:endParaRPr lang="en-US"/>
+          </a:p>
+        </p:txBody>
       </p:sp>
       <p:sp>
         <p:nvSpPr>
@@ -4999,7 +5093,7 @@
           <a:bodyPr wrap="square" rtlCol="0" anchor="ctr"/>
           <a:lstStyle/>
           <a:p>
-            <a:pPr algn="ctr" indent="0" marL="0">
+            <a:pPr marL="0" indent="0" algn="ctr">
               <a:buNone/>
             </a:pPr>
             <a:r>
@@ -5017,6 +5111,36 @@
           </a:p>
         </p:txBody>
       </p:sp>
+      <p:pic>
+        <p:nvPicPr>
+          <p:cNvPr id="12" name="Picture 11" descr="A blue and white logo&#10;&#10;AI-generated content may be incorrect.">
+            <a:extLst>
+              <a:ext uri="{FF2B5EF4-FFF2-40B4-BE49-F238E27FC236}">
+                <a16:creationId xmlns:a16="http://schemas.microsoft.com/office/drawing/2014/main" id="{3A193F97-C9CF-65D3-1F9C-15DD8F8AA863}"/>
+              </a:ext>
+            </a:extLst>
+          </p:cNvPr>
+          <p:cNvPicPr>
+            <a:picLocks noChangeAspect="1"/>
+          </p:cNvPicPr>
+          <p:nvPr/>
+        </p:nvPicPr>
+        <p:blipFill>
+          <a:blip r:embed="rId3"/>
+          <a:stretch>
+            <a:fillRect/>
+          </a:stretch>
+        </p:blipFill>
+        <p:spPr>
+          <a:xfrm>
+            <a:off x="3123268" y="306161"/>
+            <a:ext cx="2897464" cy="1373264"/>
+          </a:xfrm>
+          <a:prstGeom prst="rect">
+            <a:avLst/>
+          </a:prstGeom>
+        </p:spPr>
+      </p:pic>
     </p:spTree>
   </p:cSld>
   <p:clrMapOvr>
@@ -5318,4 +5442,319 @@
     </a:ext>
   </a:extLst>
 </a:theme>
+</file>
+
+<file path=ppt/theme/theme2.xml><?xml version="1.0" encoding="utf-8"?>
+<a:theme xmlns:a="http://schemas.openxmlformats.org/drawingml/2006/main" name="Office Theme">
+  <a:themeElements>
+    <a:clrScheme name="Office">
+      <a:dk1>
+        <a:sysClr val="windowText" lastClr="000000"/>
+      </a:dk1>
+      <a:lt1>
+        <a:sysClr val="window" lastClr="FFFFFF"/>
+      </a:lt1>
+      <a:dk2>
+        <a:srgbClr val="0E2841"/>
+      </a:dk2>
+      <a:lt2>
+        <a:srgbClr val="E8E8E8"/>
+      </a:lt2>
+      <a:accent1>
+        <a:srgbClr val="156082"/>
+      </a:accent1>
+      <a:accent2>
+        <a:srgbClr val="E97132"/>
+      </a:accent2>
+      <a:accent3>
+        <a:srgbClr val="196B24"/>
+      </a:accent3>
+      <a:accent4>
+        <a:srgbClr val="0F9ED5"/>
+      </a:accent4>
+      <a:accent5>
+        <a:srgbClr val="A02B93"/>
+      </a:accent5>
+      <a:accent6>
+        <a:srgbClr val="4EA72E"/>
+      </a:accent6>
+      <a:hlink>
+        <a:srgbClr val="467886"/>
+      </a:hlink>
+      <a:folHlink>
+        <a:srgbClr val="96607D"/>
+      </a:folHlink>
+    </a:clrScheme>
+    <a:fontScheme name="Office">
+      <a:majorFont>
+        <a:latin typeface="Aptos Display" panose="02110004020202020204"/>
+        <a:ea typeface=""/>
+        <a:cs typeface=""/>
+        <a:font script="Jpan" typeface="游ゴシック Light"/>
+        <a:font script="Hang" typeface="맑은 고딕"/>
+        <a:font script="Hans" typeface="等线 Light"/>
+        <a:font script="Hant" typeface="新細明體"/>
+        <a:font script="Arab" typeface="Times New Roman"/>
+        <a:font script="Hebr" typeface="Times New Roman"/>
+        <a:font script="Thai" typeface="Angsana New"/>
+        <a:font script="Ethi" typeface="Nyala"/>
+        <a:font script="Beng" typeface="Vrinda"/>
+        <a:font script="Gujr" typeface="Shruti"/>
+        <a:font script="Khmr" typeface="MoolBoran"/>
+        <a:font script="Knda" typeface="Tunga"/>
+        <a:font script="Guru" typeface="Raavi"/>
+        <a:font script="Cans" typeface="Euphemia"/>
+        <a:font script="Cher" typeface="Plantagenet Cherokee"/>
+        <a:font script="Yiii" typeface="Microsoft Yi Baiti"/>
+        <a:font script="Tibt" typeface="Microsoft Himalaya"/>
+        <a:font script="Thaa" typeface="MV Boli"/>
+        <a:font script="Deva" typeface="Mangal"/>
+        <a:font script="Telu" typeface="Gautami"/>
+        <a:font script="Taml" typeface="Latha"/>
+        <a:font script="Syrc" typeface="Estrangelo Edessa"/>
+        <a:font script="Orya" typeface="Kalinga"/>
+        <a:font script="Mlym" typeface="Kartika"/>
+        <a:font script="Laoo" typeface="DokChampa"/>
+        <a:font script="Sinh" typeface="Iskoola Pota"/>
+        <a:font script="Mong" typeface="Mongolian Baiti"/>
+        <a:font script="Viet" typeface="Times New Roman"/>
+        <a:font script="Uigh" typeface="Microsoft Uighur"/>
+        <a:font script="Geor" typeface="Sylfaen"/>
+        <a:font script="Armn" typeface="Arial"/>
+        <a:font script="Bugi" typeface="Leelawadee UI"/>
+        <a:font script="Bopo" typeface="Microsoft JhengHei"/>
+        <a:font script="Java" typeface="Javanese Text"/>
+        <a:font script="Lisu" typeface="Segoe UI"/>
+        <a:font script="Mymr" typeface="Myanmar Text"/>
+        <a:font script="Nkoo" typeface="Ebrima"/>
+        <a:font script="Olck" typeface="Nirmala UI"/>
+        <a:font script="Osma" typeface="Ebrima"/>
+        <a:font script="Phag" typeface="Phagspa"/>
+        <a:font script="Syrn" typeface="Estrangelo Edessa"/>
+        <a:font script="Syrj" typeface="Estrangelo Edessa"/>
+        <a:font script="Syre" typeface="Estrangelo Edessa"/>
+        <a:font script="Sora" typeface="Nirmala UI"/>
+        <a:font script="Tale" typeface="Microsoft Tai Le"/>
+        <a:font script="Talu" typeface="Microsoft New Tai Lue"/>
+        <a:font script="Tfng" typeface="Ebrima"/>
+      </a:majorFont>
+      <a:minorFont>
+        <a:latin typeface="Aptos" panose="02110004020202020204"/>
+        <a:ea typeface=""/>
+        <a:cs typeface=""/>
+        <a:font script="Jpan" typeface="游ゴシック"/>
+        <a:font script="Hang" typeface="맑은 고딕"/>
+        <a:font script="Hans" typeface="等线"/>
+        <a:font script="Hant" typeface="新細明體"/>
+        <a:font script="Arab" typeface="Arial"/>
+        <a:font script="Hebr" typeface="Arial"/>
+        <a:font script="Thai" typeface="Cordia New"/>
+        <a:font script="Ethi" typeface="Nyala"/>
+        <a:font script="Beng" typeface="Vrinda"/>
+        <a:font script="Gujr" typeface="Shruti"/>
+        <a:font script="Khmr" typeface="DaunPenh"/>
+        <a:font script="Knda" typeface="Tunga"/>
+        <a:font script="Guru" typeface="Raavi"/>
+        <a:font script="Cans" typeface="Euphemia"/>
+        <a:font script="Cher" typeface="Plantagenet Cherokee"/>
+        <a:font script="Yiii" typeface="Microsoft Yi Baiti"/>
+        <a:font script="Tibt" typeface="Microsoft Himalaya"/>
+        <a:font script="Thaa" typeface="MV Boli"/>
+        <a:font script="Deva" typeface="Mangal"/>
+        <a:font script="Telu" typeface="Gautami"/>
+        <a:font script="Taml" typeface="Latha"/>
+        <a:font script="Syrc" typeface="Estrangelo Edessa"/>
+        <a:font script="Orya" typeface="Kalinga"/>
+        <a:font script="Mlym" typeface="Kartika"/>
+        <a:font script="Laoo" typeface="DokChampa"/>
+        <a:font script="Sinh" typeface="Iskoola Pota"/>
+        <a:font script="Mong" typeface="Mongolian Baiti"/>
+        <a:font script="Viet" typeface="Arial"/>
+        <a:font script="Uigh" typeface="Microsoft Uighur"/>
+        <a:font script="Geor" typeface="Sylfaen"/>
+        <a:font script="Armn" typeface="Arial"/>
+        <a:font script="Bugi" typeface="Leelawadee UI"/>
+        <a:font script="Bopo" typeface="Microsoft JhengHei"/>
+        <a:font script="Java" typeface="Javanese Text"/>
+        <a:font script="Lisu" typeface="Segoe UI"/>
+        <a:font script="Mymr" typeface="Myanmar Text"/>
+        <a:font script="Nkoo" typeface="Ebrima"/>
+        <a:font script="Olck" typeface="Nirmala UI"/>
+        <a:font script="Osma" typeface="Ebrima"/>
+        <a:font script="Phag" typeface="Phagspa"/>
+        <a:font script="Syrn" typeface="Estrangelo Edessa"/>
+        <a:font script="Syrj" typeface="Estrangelo Edessa"/>
+        <a:font script="Syre" typeface="Estrangelo Edessa"/>
+        <a:font script="Sora" typeface="Nirmala UI"/>
+        <a:font script="Tale" typeface="Microsoft Tai Le"/>
+        <a:font script="Talu" typeface="Microsoft New Tai Lue"/>
+        <a:font script="Tfng" typeface="Ebrima"/>
+      </a:minorFont>
+    </a:fontScheme>
+    <a:fmtScheme name="Office">
+      <a:fillStyleLst>
+        <a:solidFill>
+          <a:schemeClr val="phClr"/>
+        </a:solidFill>
+        <a:gradFill rotWithShape="1">
+          <a:gsLst>
+            <a:gs pos="0">
+              <a:schemeClr val="phClr">
+                <a:lumMod val="110000"/>
+                <a:satMod val="105000"/>
+                <a:tint val="67000"/>
+              </a:schemeClr>
+            </a:gs>
+            <a:gs pos="50000">
+              <a:schemeClr val="phClr">
+                <a:lumMod val="105000"/>
+                <a:satMod val="103000"/>
+                <a:tint val="73000"/>
+              </a:schemeClr>
+            </a:gs>
+            <a:gs pos="100000">
+              <a:schemeClr val="phClr">
+                <a:lumMod val="105000"/>
+                <a:satMod val="109000"/>
+                <a:tint val="81000"/>
+              </a:schemeClr>
+            </a:gs>
+          </a:gsLst>
+          <a:lin ang="5400000" scaled="0"/>
+        </a:gradFill>
+        <a:gradFill rotWithShape="1">
+          <a:gsLst>
+            <a:gs pos="0">
+              <a:schemeClr val="phClr">
+                <a:satMod val="103000"/>
+                <a:lumMod val="102000"/>
+                <a:tint val="94000"/>
+              </a:schemeClr>
+            </a:gs>
+            <a:gs pos="50000">
+              <a:schemeClr val="phClr">
+                <a:satMod val="110000"/>
+                <a:lumMod val="100000"/>
+                <a:shade val="100000"/>
+              </a:schemeClr>
+            </a:gs>
+            <a:gs pos="100000">
+              <a:schemeClr val="phClr">
+                <a:lumMod val="99000"/>
+                <a:satMod val="120000"/>
+                <a:shade val="78000"/>
+              </a:schemeClr>
+            </a:gs>
+          </a:gsLst>
+          <a:lin ang="5400000" scaled="0"/>
+        </a:gradFill>
+      </a:fillStyleLst>
+      <a:lnStyleLst>
+        <a:ln w="12700" cap="flat" cmpd="sng" algn="ctr">
+          <a:solidFill>
+            <a:schemeClr val="phClr"/>
+          </a:solidFill>
+          <a:prstDash val="solid"/>
+          <a:miter lim="800000"/>
+        </a:ln>
+        <a:ln w="19050" cap="flat" cmpd="sng" algn="ctr">
+          <a:solidFill>
+            <a:schemeClr val="phClr"/>
+          </a:solidFill>
+          <a:prstDash val="solid"/>
+          <a:miter lim="800000"/>
+        </a:ln>
+        <a:ln w="25400" cap="flat" cmpd="sng" algn="ctr">
+          <a:solidFill>
+            <a:schemeClr val="phClr"/>
+          </a:solidFill>
+          <a:prstDash val="solid"/>
+          <a:miter lim="800000"/>
+        </a:ln>
+      </a:lnStyleLst>
+      <a:effectStyleLst>
+        <a:effectStyle>
+          <a:effectLst/>
+        </a:effectStyle>
+        <a:effectStyle>
+          <a:effectLst/>
+        </a:effectStyle>
+        <a:effectStyle>
+          <a:effectLst>
+            <a:outerShdw blurRad="57150" dist="19050" dir="5400000" algn="ctr" rotWithShape="0">
+              <a:srgbClr val="000000">
+                <a:alpha val="63000"/>
+              </a:srgbClr>
+            </a:outerShdw>
+          </a:effectLst>
+        </a:effectStyle>
+      </a:effectStyleLst>
+      <a:bgFillStyleLst>
+        <a:solidFill>
+          <a:schemeClr val="phClr"/>
+        </a:solidFill>
+        <a:solidFill>
+          <a:schemeClr val="phClr">
+            <a:tint val="95000"/>
+            <a:satMod val="170000"/>
+          </a:schemeClr>
+        </a:solidFill>
+        <a:gradFill rotWithShape="1">
+          <a:gsLst>
+            <a:gs pos="0">
+              <a:schemeClr val="phClr">
+                <a:tint val="93000"/>
+                <a:satMod val="150000"/>
+                <a:shade val="98000"/>
+                <a:lumMod val="102000"/>
+              </a:schemeClr>
+            </a:gs>
+            <a:gs pos="50000">
+              <a:schemeClr val="phClr">
+                <a:tint val="98000"/>
+                <a:satMod val="130000"/>
+                <a:shade val="90000"/>
+                <a:lumMod val="103000"/>
+              </a:schemeClr>
+            </a:gs>
+            <a:gs pos="100000">
+              <a:schemeClr val="phClr">
+                <a:shade val="63000"/>
+                <a:satMod val="120000"/>
+              </a:schemeClr>
+            </a:gs>
+          </a:gsLst>
+          <a:lin ang="5400000" scaled="0"/>
+        </a:gradFill>
+      </a:bgFillStyleLst>
+    </a:fmtScheme>
+  </a:themeElements>
+  <a:objectDefaults>
+    <a:lnDef>
+      <a:spPr/>
+      <a:bodyPr/>
+      <a:lstStyle/>
+      <a:style>
+        <a:lnRef idx="2">
+          <a:schemeClr val="accent1"/>
+        </a:lnRef>
+        <a:fillRef idx="0">
+          <a:schemeClr val="accent1"/>
+        </a:fillRef>
+        <a:effectRef idx="1">
+          <a:schemeClr val="accent1"/>
+        </a:effectRef>
+        <a:fontRef idx="minor">
+          <a:schemeClr val="tx1"/>
+        </a:fontRef>
+      </a:style>
+    </a:lnDef>
+  </a:objectDefaults>
+  <a:extraClrSchemeLst/>
+  <a:extLst>
+    <a:ext uri="{05A4C25C-085E-4340-85A3-A5531E510DB2}">
+      <thm15:themeFamily xmlns:thm15="http://schemas.microsoft.com/office/thememl/2012/main" name="Office Theme" id="{2E142A2C-CD16-42D6-873A-C26D2A0506FA}" vid="{1BDDFF52-6CD6-40A5-AB3C-68EB2F1E4D0A}"/>
+    </a:ext>
+  </a:extLst>
+</a:theme>
 </file>
</xml_diff>